<commit_message>
docs: presentacion v2 con capturas reales (10 slides) + evidencias + scripts puppeteer
</commit_message>
<xml_diff>
--- a/docs/presentacion.pptx
+++ b/docs/presentacion.pptx
@@ -511,8 +511,9 @@
           <a:p>
             <a:r>
               <a:rPr lang="en-US" dirty="0"/>
-              <a:t>Presentación pensada para 10 láminas × ~1min 15s cada una = 12 min.
-Se convierte a PDF con: marp docs/presentacion.md -o docs/presentacion.pdf</a:t>
+              <a:t>Se convierte a PDF/PPTX con:
+  npx @marp-team/marp-cli docs/presentacion.md --allow-local-files -o docs/presentacion.pdf
+  npx @marp-team/marp-cli docs/presentacion.md --allow-local-files -o docs/presentacion.pptx</a:t>
             </a:r>
             <a:endParaRPr lang="en-US" dirty="0"/>
           </a:p>

</xml_diff>